<commit_message>
Update presentation: Q1 2025 forecast, LSTM wins, Cloud Run deployment, corrected metrics
- Title: Q1 2025 forecast, June 2026, Streamlit + Cloud Run replaces Tableau
- Slide 2: objective updated to full 2020–2024 + Q1 2025
- Slide 4: MASE as primary metric, MAPE excluded, Cloud Run deployment
- Slide 5: LSTM arch updated (LSTM(32)+Dense(30)), correct MASE/MAE values
- Slide 6: LSTM wins framing, correct holdout numbers
- Slide 7: updated forecasting accuracy finding
- Slide 8: folder names (02_SRC, 01_database, 04_outputs)
- Slide 9: updated conclusions, Cloud Run live URL

Co-Authored-By: Claude Sonnet 4.6 <noreply@anthropic.com>
</commit_message>
<xml_diff>
--- a/Bikes_Sales_Forecast_Presentation.pptx
+++ b/Bikes_Sales_Forecast_Presentation.pptx
@@ -1983,6 +1983,10 @@
             <a:prstDash val="solid"/>
           </a:ln>
         </p:spPr>
+        <p:txBody>
+          <a:bodyPr/>
+          <a:p/>
+        </p:txBody>
       </p:sp>
       <p:sp>
         <p:nvSpPr>
@@ -2008,6 +2012,10 @@
             <a:prstDash val="solid"/>
           </a:ln>
         </p:spPr>
+        <p:txBody>
+          <a:bodyPr/>
+          <a:p/>
+        </p:txBody>
       </p:sp>
       <p:sp>
         <p:nvSpPr>
@@ -2033,6 +2041,10 @@
             <a:prstDash val="solid"/>
           </a:ln>
         </p:spPr>
+        <p:txBody>
+          <a:bodyPr/>
+          <a:p/>
+        </p:txBody>
       </p:sp>
       <p:sp>
         <p:nvSpPr>
@@ -2106,7 +2118,7 @@
                 <a:ea typeface="Calibri" pitchFamily="34" charset="-122"/>
                 <a:cs typeface="Calibri" pitchFamily="34" charset="-120"/>
               </a:rPr>
-              <a:t>Sales Performance Analysis &amp; Q4 2024 Forecast</a:t>
+              <a:t>Sales Performance Analysis &amp; Q1 2025 Forecast</a:t>
             </a:r>
             <a:endParaRPr lang="en-US" sz="2000" dirty="0"/>
           </a:p>
@@ -2134,6 +2146,10 @@
             <a:prstDash val="solid"/>
           </a:ln>
         </p:spPr>
+        <p:txBody>
+          <a:bodyPr/>
+          <a:p/>
+        </p:txBody>
       </p:sp>
       <p:sp>
         <p:nvSpPr>
@@ -2182,7 +2198,7 @@
                 <a:ea typeface="Calibri" pitchFamily="34" charset="-122"/>
                 <a:cs typeface="Calibri" pitchFamily="34" charset="-120"/>
               </a:rPr>
-              <a:t>  |  Ella Ndalla  |  March 2026</a:t>
+              <a:t>  |  Ella Ndalla  |  June 2026</a:t>
             </a:r>
             <a:endParaRPr lang="en-US" sz="1300" dirty="0"/>
           </a:p>
@@ -2212,6 +2228,10 @@
             <a:prstDash val="solid"/>
           </a:ln>
         </p:spPr>
+        <p:txBody>
+          <a:bodyPr/>
+          <a:p/>
+        </p:txBody>
       </p:sp>
       <p:sp>
         <p:nvSpPr>
@@ -2276,6 +2296,10 @@
             <a:prstDash val="solid"/>
           </a:ln>
         </p:spPr>
+        <p:txBody>
+          <a:bodyPr/>
+          <a:p/>
+        </p:txBody>
       </p:sp>
       <p:sp>
         <p:nvSpPr>
@@ -2340,6 +2364,10 @@
             <a:prstDash val="solid"/>
           </a:ln>
         </p:spPr>
+        <p:txBody>
+          <a:bodyPr/>
+          <a:p/>
+        </p:txBody>
       </p:sp>
       <p:sp>
         <p:nvSpPr>
@@ -2404,6 +2432,10 @@
             <a:prstDash val="solid"/>
           </a:ln>
         </p:spPr>
+        <p:txBody>
+          <a:bodyPr/>
+          <a:p/>
+        </p:txBody>
       </p:sp>
       <p:sp>
         <p:nvSpPr>
@@ -2468,6 +2500,10 @@
             <a:prstDash val="solid"/>
           </a:ln>
         </p:spPr>
+        <p:txBody>
+          <a:bodyPr/>
+          <a:p/>
+        </p:txBody>
       </p:sp>
       <p:sp>
         <p:nvSpPr>
@@ -2502,7 +2538,7 @@
                 <a:ea typeface="Calibri" pitchFamily="34" charset="-122"/>
                 <a:cs typeface="Calibri" pitchFamily="34" charset="-120"/>
               </a:rPr>
-              <a:t>Tableau</a:t>
+              <a:t>Streamlit + Cloud Run</a:t>
             </a:r>
             <a:endParaRPr lang="en-US" sz="1000" dirty="0"/>
           </a:p>
@@ -2564,6 +2600,10 @@
             <a:prstDash val="solid"/>
           </a:ln>
         </p:spPr>
+        <p:txBody>
+          <a:bodyPr/>
+          <a:p/>
+        </p:txBody>
       </p:sp>
       <p:sp>
         <p:nvSpPr>
@@ -2630,6 +2670,10 @@
             </a:outerShdw>
           </a:effectLst>
         </p:spPr>
+        <p:txBody>
+          <a:bodyPr/>
+          <a:p/>
+        </p:txBody>
       </p:sp>
       <p:sp>
         <p:nvSpPr>
@@ -2655,6 +2699,10 @@
             <a:prstDash val="solid"/>
           </a:ln>
         </p:spPr>
+        <p:txBody>
+          <a:bodyPr/>
+          <a:p/>
+        </p:txBody>
       </p:sp>
       <p:sp>
         <p:nvSpPr>
@@ -2757,7 +2805,7 @@
                 <a:ea typeface="Calibri" pitchFamily="34" charset="-122"/>
                 <a:cs typeface="Calibri" pitchFamily="34" charset="-120"/>
               </a:rPr>
-              <a:t>Analyze sales performance for Q1–Q3 2024 and generate accurate Q4 2024 forecasts.
+              <a:t>Analyze full-year 2020–2024 sales performance and generate accurate Q1 2025 revenue forecasts.
 </a:t>
             </a:r>
             <a:pPr algn="l" indent="0" marL="0">
@@ -2849,6 +2897,10 @@
             </a:outerShdw>
           </a:effectLst>
         </p:spPr>
+        <p:txBody>
+          <a:bodyPr/>
+          <a:p/>
+        </p:txBody>
       </p:sp>
       <p:sp>
         <p:nvSpPr>
@@ -2874,6 +2926,10 @@
             <a:prstDash val="solid"/>
           </a:ln>
         </p:spPr>
+        <p:txBody>
+          <a:bodyPr/>
+          <a:p/>
+        </p:txBody>
       </p:sp>
       <p:sp>
         <p:nvSpPr>
@@ -2938,6 +2994,10 @@
             <a:prstDash val="solid"/>
           </a:ln>
         </p:spPr>
+        <p:txBody>
+          <a:bodyPr/>
+          <a:p/>
+        </p:txBody>
       </p:sp>
       <p:sp>
         <p:nvSpPr>
@@ -3041,6 +3101,10 @@
             <a:prstDash val="solid"/>
           </a:ln>
         </p:spPr>
+        <p:txBody>
+          <a:bodyPr/>
+          <a:p/>
+        </p:txBody>
       </p:sp>
       <p:sp>
         <p:nvSpPr>
@@ -3144,6 +3208,10 @@
             <a:prstDash val="solid"/>
           </a:ln>
         </p:spPr>
+        <p:txBody>
+          <a:bodyPr/>
+          <a:p/>
+        </p:txBody>
       </p:sp>
       <p:sp>
         <p:nvSpPr>
@@ -3247,6 +3315,10 @@
             <a:prstDash val="solid"/>
           </a:ln>
         </p:spPr>
+        <p:txBody>
+          <a:bodyPr/>
+          <a:p/>
+        </p:txBody>
       </p:sp>
       <p:sp>
         <p:nvSpPr>
@@ -4978,6 +5050,10 @@
             <a:prstDash val="solid"/>
           </a:ln>
         </p:spPr>
+        <p:txBody>
+          <a:bodyPr/>
+          <a:p/>
+        </p:txBody>
       </p:sp>
       <p:sp>
         <p:nvSpPr>
@@ -5044,6 +5120,10 @@
             </a:outerShdw>
           </a:effectLst>
         </p:spPr>
+        <p:txBody>
+          <a:bodyPr/>
+          <a:p/>
+        </p:txBody>
       </p:sp>
       <p:sp>
         <p:nvSpPr>
@@ -5069,6 +5149,10 @@
             <a:prstDash val="solid"/>
           </a:ln>
         </p:spPr>
+        <p:txBody>
+          <a:bodyPr/>
+          <a:p/>
+        </p:txBody>
       </p:sp>
       <p:sp>
         <p:nvSpPr>
@@ -5211,6 +5295,10 @@
             </a:outerShdw>
           </a:effectLst>
         </p:spPr>
+        <p:txBody>
+          <a:bodyPr/>
+          <a:p/>
+        </p:txBody>
       </p:sp>
       <p:sp>
         <p:nvSpPr>
@@ -5236,6 +5324,10 @@
             <a:prstDash val="solid"/>
           </a:ln>
         </p:spPr>
+        <p:txBody>
+          <a:bodyPr/>
+          <a:p/>
+        </p:txBody>
       </p:sp>
       <p:sp>
         <p:nvSpPr>
@@ -5378,6 +5470,10 @@
             </a:outerShdw>
           </a:effectLst>
         </p:spPr>
+        <p:txBody>
+          <a:bodyPr/>
+          <a:p/>
+        </p:txBody>
       </p:sp>
       <p:sp>
         <p:nvSpPr>
@@ -5403,6 +5499,10 @@
             <a:prstDash val="solid"/>
           </a:ln>
         </p:spPr>
+        <p:txBody>
+          <a:bodyPr/>
+          <a:p/>
+        </p:txBody>
       </p:sp>
       <p:sp>
         <p:nvSpPr>
@@ -5545,6 +5645,10 @@
             </a:outerShdw>
           </a:effectLst>
         </p:spPr>
+        <p:txBody>
+          <a:bodyPr/>
+          <a:p/>
+        </p:txBody>
       </p:sp>
       <p:sp>
         <p:nvSpPr>
@@ -5570,6 +5674,10 @@
             <a:prstDash val="solid"/>
           </a:ln>
         </p:spPr>
+        <p:txBody>
+          <a:bodyPr/>
+          <a:p/>
+        </p:txBody>
       </p:sp>
       <p:sp>
         <p:nvSpPr>
@@ -5680,7 +5788,7 @@
                 <a:ea typeface="Calibri" pitchFamily="34" charset="-122"/>
                 <a:cs typeface="Calibri" pitchFamily="34" charset="-120"/>
               </a:rPr>
-              <a:t>Keras Tuner optimization</a:t>
+              <a:t>Fixed lightweight architecture (LSTM(32) + Dense(30))</a:t>
             </a:r>
             <a:endParaRPr lang="en-US" sz="1100" dirty="0"/>
           </a:p>
@@ -5712,6 +5820,10 @@
             </a:outerShdw>
           </a:effectLst>
         </p:spPr>
+        <p:txBody>
+          <a:bodyPr/>
+          <a:p/>
+        </p:txBody>
       </p:sp>
       <p:sp>
         <p:nvSpPr>
@@ -5737,6 +5849,10 @@
             <a:prstDash val="solid"/>
           </a:ln>
         </p:spPr>
+        <p:txBody>
+          <a:bodyPr/>
+          <a:p/>
+        </p:txBody>
       </p:sp>
       <p:sp>
         <p:nvSpPr>
@@ -5811,7 +5927,7 @@
                 <a:ea typeface="Calibri" pitchFamily="34" charset="-122"/>
                 <a:cs typeface="Calibri" pitchFamily="34" charset="-120"/>
               </a:rPr>
-              <a:t>MAPE &amp; MSPE for AutoARIMA</a:t>
+              <a:t>MASE (primary) — scale-free, baseline-anchored</a:t>
             </a:r>
             <a:endParaRPr lang="en-US" sz="1100" dirty="0"/>
           </a:p>
@@ -5829,7 +5945,7 @@
                 <a:ea typeface="Calibri" pitchFamily="34" charset="-122"/>
                 <a:cs typeface="Calibri" pitchFamily="34" charset="-120"/>
               </a:rPr>
-              <a:t>MAE &amp; MSE for LSTM</a:t>
+              <a:t>MAE &amp; RMSE per model on same holdout window</a:t>
             </a:r>
             <a:endParaRPr lang="en-US" sz="1100" dirty="0"/>
           </a:p>
@@ -5847,7 +5963,7 @@
                 <a:ea typeface="Calibri" pitchFamily="34" charset="-122"/>
                 <a:cs typeface="Calibri" pitchFamily="34" charset="-120"/>
               </a:rPr>
-              <a:t>Cross-model comparison</a:t>
+              <a:t>MAPE excluded — explodes near zero-value actuals</a:t>
             </a:r>
             <a:endParaRPr lang="en-US" sz="1100" dirty="0"/>
           </a:p>
@@ -5879,6 +5995,10 @@
             </a:outerShdw>
           </a:effectLst>
         </p:spPr>
+        <p:txBody>
+          <a:bodyPr/>
+          <a:p/>
+        </p:txBody>
       </p:sp>
       <p:sp>
         <p:nvSpPr>
@@ -5904,6 +6024,10 @@
             <a:prstDash val="solid"/>
           </a:ln>
         </p:spPr>
+        <p:txBody>
+          <a:bodyPr/>
+          <a:p/>
+        </p:txBody>
       </p:sp>
       <p:sp>
         <p:nvSpPr>
@@ -5978,7 +6102,7 @@
                 <a:ea typeface="Calibri" pitchFamily="34" charset="-122"/>
                 <a:cs typeface="Calibri" pitchFamily="34" charset="-120"/>
               </a:rPr>
-              <a:t>Tableau Public dashboard</a:t>
+              <a:t>Streamlit dashboard deployed on Google Cloud Run</a:t>
             </a:r>
             <a:endParaRPr lang="en-US" sz="1100" dirty="0"/>
           </a:p>
@@ -5996,7 +6120,7 @@
                 <a:ea typeface="Calibri" pitchFamily="34" charset="-122"/>
                 <a:cs typeface="Calibri" pitchFamily="34" charset="-120"/>
               </a:rPr>
-              <a:t>Predictions exported to CSV/PKL</a:t>
+              <a:t>Pre-computed predictions committed to 04_outputs/</a:t>
             </a:r>
             <a:endParaRPr lang="en-US" sz="1100" dirty="0"/>
           </a:p>
@@ -6076,6 +6200,10 @@
             <a:prstDash val="solid"/>
           </a:ln>
         </p:spPr>
+        <p:txBody>
+          <a:bodyPr/>
+          <a:p/>
+        </p:txBody>
       </p:sp>
       <p:sp>
         <p:nvSpPr>
@@ -6142,6 +6270,10 @@
             </a:outerShdw>
           </a:effectLst>
         </p:spPr>
+        <p:txBody>
+          <a:bodyPr/>
+          <a:p/>
+        </p:txBody>
       </p:sp>
       <p:sp>
         <p:nvSpPr>
@@ -6167,6 +6299,10 @@
             <a:prstDash val="solid"/>
           </a:ln>
         </p:spPr>
+        <p:txBody>
+          <a:bodyPr/>
+          <a:p/>
+        </p:txBody>
       </p:sp>
       <p:sp>
         <p:nvSpPr>
@@ -6364,6 +6500,10 @@
             <a:prstDash val="solid"/>
           </a:ln>
         </p:spPr>
+        <p:txBody>
+          <a:bodyPr/>
+          <a:p/>
+        </p:txBody>
       </p:sp>
       <p:sp>
         <p:nvSpPr>
@@ -6398,7 +6538,7 @@
                 <a:ea typeface="Calibri" pitchFamily="34" charset="-122"/>
                 <a:cs typeface="Calibri" pitchFamily="34" charset="-120"/>
               </a:rPr>
-              <a:t>MAPE</a:t>
+              <a:t>MASE</a:t>
             </a:r>
             <a:endParaRPr lang="en-US" sz="1600" dirty="0"/>
           </a:p>
@@ -6415,7 +6555,7 @@
                 <a:ea typeface="Calibri" pitchFamily="34" charset="-122"/>
                 <a:cs typeface="Calibri" pitchFamily="34" charset="-120"/>
               </a:rPr>
-              <a:t>20.9%</a:t>
+              <a:t>0.778</a:t>
             </a:r>
             <a:endParaRPr lang="en-US" sz="1600" dirty="0"/>
           </a:p>
@@ -6445,6 +6585,10 @@
             <a:prstDash val="solid"/>
           </a:ln>
         </p:spPr>
+        <p:txBody>
+          <a:bodyPr/>
+          <a:p/>
+        </p:txBody>
       </p:sp>
       <p:sp>
         <p:nvSpPr>
@@ -6479,7 +6623,7 @@
                 <a:ea typeface="Calibri" pitchFamily="34" charset="-122"/>
                 <a:cs typeface="Calibri" pitchFamily="34" charset="-120"/>
               </a:rPr>
-              <a:t>MASE</a:t>
+              <a:t>MAE</a:t>
             </a:r>
             <a:endParaRPr lang="en-US" sz="1600" dirty="0"/>
           </a:p>
@@ -6496,7 +6640,7 @@
                 <a:ea typeface="Calibri" pitchFamily="34" charset="-122"/>
                 <a:cs typeface="Calibri" pitchFamily="34" charset="-120"/>
               </a:rPr>
-              <a:t>0.45</a:t>
+              <a:t>$34,688</a:t>
             </a:r>
             <a:endParaRPr lang="en-US" sz="1600" dirty="0"/>
           </a:p>
@@ -6528,6 +6672,10 @@
             </a:outerShdw>
           </a:effectLst>
         </p:spPr>
+        <p:txBody>
+          <a:bodyPr/>
+          <a:p/>
+        </p:txBody>
       </p:sp>
       <p:sp>
         <p:nvSpPr>
@@ -6553,6 +6701,10 @@
             <a:prstDash val="solid"/>
           </a:ln>
         </p:spPr>
+        <p:txBody>
+          <a:bodyPr/>
+          <a:p/>
+        </p:txBody>
       </p:sp>
       <p:sp>
         <p:nvSpPr>
@@ -6666,7 +6818,7 @@
                 <a:ea typeface="Calibri" pitchFamily="34" charset="-122"/>
                 <a:cs typeface="Calibri" pitchFamily="34" charset="-120"/>
               </a:rPr>
-              <a:t>Architecture: 1 LSTM (256 units) + 3 Dense layers (80, 16, 11)</a:t>
+              <a:t>Architecture: Input(3, 30) → LSTM(32) → Dense(30)</a:t>
             </a:r>
             <a:endParaRPr lang="en-US" sz="1200" dirty="0"/>
           </a:p>
@@ -6684,7 +6836,7 @@
                 <a:ea typeface="Calibri" pitchFamily="34" charset="-122"/>
                 <a:cs typeface="Calibri" pitchFamily="34" charset="-120"/>
               </a:rPr>
-              <a:t>889,428 total parameters (296,475 trainable)</a:t>
+              <a:t>9,054 trainable parameters — lightweight, fast convergence</a:t>
             </a:r>
             <a:endParaRPr lang="en-US" sz="1200" dirty="0"/>
           </a:p>
@@ -6702,7 +6854,7 @@
                 <a:ea typeface="Calibri" pitchFamily="34" charset="-122"/>
                 <a:cs typeface="Calibri" pitchFamily="34" charset="-120"/>
               </a:rPr>
-              <a:t>Keras Tuner optimized to minimize validation loss</a:t>
+              <a:t>Early stopping (patience=5); no Keras Tuner — fixed architecture</a:t>
             </a:r>
             <a:endParaRPr lang="en-US" sz="1200" dirty="0"/>
           </a:p>
@@ -6720,7 +6872,7 @@
                 <a:ea typeface="Calibri" pitchFamily="34" charset="-122"/>
                 <a:cs typeface="Calibri" pitchFamily="34" charset="-120"/>
               </a:rPr>
-              <a:t>Scaled &amp; split with TensorFlow Datasets</a:t>
+              <a:t>TF not a runtime dep — predictions pre-computed &amp; committed</a:t>
             </a:r>
             <a:endParaRPr lang="en-US" sz="1200" dirty="0"/>
           </a:p>
@@ -6750,6 +6902,10 @@
             <a:prstDash val="solid"/>
           </a:ln>
         </p:spPr>
+        <p:txBody>
+          <a:bodyPr/>
+          <a:p/>
+        </p:txBody>
       </p:sp>
       <p:sp>
         <p:nvSpPr>
@@ -6784,7 +6940,7 @@
                 <a:ea typeface="Calibri" pitchFamily="34" charset="-122"/>
                 <a:cs typeface="Calibri" pitchFamily="34" charset="-120"/>
               </a:rPr>
-              <a:t>MAE</a:t>
+              <a:t>MASE</a:t>
             </a:r>
             <a:endParaRPr lang="en-US" sz="1600" dirty="0"/>
           </a:p>
@@ -6801,7 +6957,7 @@
                 <a:ea typeface="Calibri" pitchFamily="34" charset="-122"/>
                 <a:cs typeface="Calibri" pitchFamily="34" charset="-120"/>
               </a:rPr>
-              <a:t>0.2360</a:t>
+              <a:t>0.703</a:t>
             </a:r>
             <a:endParaRPr lang="en-US" sz="1600" dirty="0"/>
           </a:p>
@@ -6831,6 +6987,10 @@
             <a:prstDash val="solid"/>
           </a:ln>
         </p:spPr>
+        <p:txBody>
+          <a:bodyPr/>
+          <a:p/>
+        </p:txBody>
       </p:sp>
       <p:sp>
         <p:nvSpPr>
@@ -6865,7 +7025,7 @@
                 <a:ea typeface="Calibri" pitchFamily="34" charset="-122"/>
                 <a:cs typeface="Calibri" pitchFamily="34" charset="-120"/>
               </a:rPr>
-              <a:t>MSE</a:t>
+              <a:t>MAE</a:t>
             </a:r>
             <a:endParaRPr lang="en-US" sz="1600" dirty="0"/>
           </a:p>
@@ -6882,7 +7042,7 @@
                 <a:ea typeface="Calibri" pitchFamily="34" charset="-122"/>
                 <a:cs typeface="Calibri" pitchFamily="34" charset="-120"/>
               </a:rPr>
-              <a:t>0.0904</a:t>
+              <a:t>$31,981</a:t>
             </a:r>
             <a:endParaRPr lang="en-US" sz="1600" dirty="0"/>
           </a:p>
@@ -6944,6 +7104,10 @@
             <a:prstDash val="solid"/>
           </a:ln>
         </p:spPr>
+        <p:txBody>
+          <a:bodyPr/>
+          <a:p/>
+        </p:txBody>
       </p:sp>
       <p:sp>
         <p:nvSpPr>
@@ -7026,6 +7190,10 @@
             </a:outerShdw>
           </a:effectLst>
         </p:spPr>
+        <p:txBody>
+          <a:bodyPr/>
+          <a:p/>
+        </p:txBody>
       </p:sp>
       <p:sp>
         <p:nvSpPr>
@@ -7051,6 +7219,10 @@
             <a:prstDash val="solid"/>
           </a:ln>
         </p:spPr>
+        <p:txBody>
+          <a:bodyPr/>
+          <a:p/>
+        </p:txBody>
       </p:sp>
       <p:sp>
         <p:nvSpPr>
@@ -7085,7 +7257,7 @@
                 <a:ea typeface="Calibri" pitchFamily="34" charset="-122"/>
                 <a:cs typeface="Calibri" pitchFamily="34" charset="-120"/>
               </a:rPr>
-              <a:t>AutoARIMA Beats Naive</a:t>
+              <a:t>Both Models Beat Naïve — LSTM Wins</a:t>
             </a:r>
             <a:endParaRPr lang="en-US" sz="1600" dirty="0"/>
           </a:p>
@@ -7124,7 +7296,7 @@
                 <a:ea typeface="Calibri" pitchFamily="34" charset="-122"/>
                 <a:cs typeface="Calibri" pitchFamily="34" charset="-120"/>
               </a:rPr>
-              <a:t>AutoARIMA scores MASE &lt; 1 at every grouping level (0.45–0.79), confirming it beats a naive forecast on real holdout data — not just a smaller error number in isolation.</a:t>
+              <a:t>Both AutoARIMA (MASE 0.778) and LSTM (MASE 0.703) beat the naïve baseline on a true 3-month holdout across all 30 bikeshops. LSTM achieves lower MAE ($31,981 vs $34,688) and lower RMSE ($38,165 vs $39,689).</a:t>
             </a:r>
             <a:endParaRPr lang="en-US" sz="1100" dirty="0"/>
           </a:p>
@@ -7156,6 +7328,10 @@
             </a:outerShdw>
           </a:effectLst>
         </p:spPr>
+        <p:txBody>
+          <a:bodyPr/>
+          <a:p/>
+        </p:txBody>
       </p:sp>
       <p:sp>
         <p:nvSpPr>
@@ -7181,6 +7357,10 @@
             <a:prstDash val="solid"/>
           </a:ln>
         </p:spPr>
+        <p:txBody>
+          <a:bodyPr/>
+          <a:p/>
+        </p:txBody>
       </p:sp>
       <p:sp>
         <p:nvSpPr>
@@ -7255,7 +7435,7 @@
                 <a:ea typeface="Calibri" pitchFamily="34" charset="-122"/>
                 <a:cs typeface="Calibri" pitchFamily="34" charset="-120"/>
               </a:rPr>
-              <a:t>AutoARIMA: smoother forecast lines</a:t>
+              <a:t>LSTM: best overall — lower MAE, RMSE, and MASE</a:t>
             </a:r>
             <a:endParaRPr lang="en-US" sz="1100" dirty="0"/>
           </a:p>
@@ -7291,7 +7471,7 @@
                 <a:ea typeface="Calibri" pitchFamily="34" charset="-122"/>
                 <a:cs typeface="Calibri" pitchFamily="34" charset="-120"/>
               </a:rPr>
-              <a:t>Naive baseline scored independently — not just folded into a ratio</a:t>
+              <a:t>Naïve MASE = 1.0 by definition — all models scored against same holdout</a:t>
             </a:r>
             <a:endParaRPr lang="en-US" sz="1100" dirty="0"/>
           </a:p>
@@ -7309,7 +7489,7 @@
                 <a:ea typeface="Calibri" pitchFamily="34" charset="-122"/>
                 <a:cs typeface="Calibri" pitchFamily="34" charset="-120"/>
               </a:rPr>
-              <a:t>LSTM scored against the same holdout via compare_arima_lstm()</a:t>
+              <a:t>AutoARIMA advantage: per-series CI bands, no GPU needed, interpretable</a:t>
             </a:r>
             <a:endParaRPr lang="en-US" sz="1100" dirty="0"/>
           </a:p>
@@ -7371,6 +7551,10 @@
             <a:prstDash val="solid"/>
           </a:ln>
         </p:spPr>
+        <p:txBody>
+          <a:bodyPr/>
+          <a:p/>
+        </p:txBody>
       </p:sp>
       <p:sp>
         <p:nvSpPr>
@@ -7435,6 +7619,10 @@
             <a:prstDash val="solid"/>
           </a:ln>
         </p:spPr>
+        <p:txBody>
+          <a:bodyPr/>
+          <a:p/>
+        </p:txBody>
       </p:sp>
       <p:sp>
         <p:nvSpPr>
@@ -7460,6 +7648,10 @@
             <a:prstDash val="solid"/>
           </a:ln>
         </p:spPr>
+        <p:txBody>
+          <a:bodyPr/>
+          <a:p/>
+        </p:txBody>
       </p:sp>
       <p:sp>
         <p:nvSpPr>
@@ -7561,6 +7753,10 @@
             <a:prstDash val="solid"/>
           </a:ln>
         </p:spPr>
+        <p:txBody>
+          <a:bodyPr/>
+          <a:p/>
+        </p:txBody>
       </p:sp>
       <p:sp>
         <p:nvSpPr>
@@ -7625,6 +7821,10 @@
             <a:prstDash val="solid"/>
           </a:ln>
         </p:spPr>
+        <p:txBody>
+          <a:bodyPr/>
+          <a:p/>
+        </p:txBody>
       </p:sp>
       <p:sp>
         <p:nvSpPr>
@@ -7650,6 +7850,10 @@
             <a:prstDash val="solid"/>
           </a:ln>
         </p:spPr>
+        <p:txBody>
+          <a:bodyPr/>
+          <a:p/>
+        </p:txBody>
       </p:sp>
       <p:sp>
         <p:nvSpPr>
@@ -7751,6 +7955,10 @@
             <a:prstDash val="solid"/>
           </a:ln>
         </p:spPr>
+        <p:txBody>
+          <a:bodyPr/>
+          <a:p/>
+        </p:txBody>
       </p:sp>
       <p:sp>
         <p:nvSpPr>
@@ -7815,6 +8023,10 @@
             <a:prstDash val="solid"/>
           </a:ln>
         </p:spPr>
+        <p:txBody>
+          <a:bodyPr/>
+          <a:p/>
+        </p:txBody>
       </p:sp>
       <p:sp>
         <p:nvSpPr>
@@ -7840,6 +8052,10 @@
             <a:prstDash val="solid"/>
           </a:ln>
         </p:spPr>
+        <p:txBody>
+          <a:bodyPr/>
+          <a:p/>
+        </p:txBody>
       </p:sp>
       <p:sp>
         <p:nvSpPr>
@@ -7941,6 +8157,10 @@
             <a:prstDash val="solid"/>
           </a:ln>
         </p:spPr>
+        <p:txBody>
+          <a:bodyPr/>
+          <a:p/>
+        </p:txBody>
       </p:sp>
       <p:sp>
         <p:nvSpPr>
@@ -7975,7 +8195,7 @@
                 <a:ea typeface="Calibri" pitchFamily="34" charset="-122"/>
                 <a:cs typeface="Calibri" pitchFamily="34" charset="-120"/>
               </a:rPr>
-              <a:t>AutoARIMA beats a naive baseline at every grouping level (MASE 0.45–0.79 vs. 1.0). AutoARIMA produces smoother, interpretable lines; LSTM gives more conservative point estimates on the same holdout.</a:t>
+              <a:t>Both models beat the naïve baseline. LSTM wins overall (MASE 0.703 vs 0.778). AutoARIMA adds value through per-series 95% CI bands and interpretable trends. MAPE excluded — MASE is the correct metric for sparse bikeshop data.</a:t>
             </a:r>
             <a:endParaRPr lang="en-US" sz="1200" dirty="0"/>
           </a:p>
@@ -8037,6 +8257,10 @@
             <a:prstDash val="solid"/>
           </a:ln>
         </p:spPr>
+        <p:txBody>
+          <a:bodyPr/>
+          <a:p/>
+        </p:txBody>
       </p:sp>
       <p:sp>
         <p:nvSpPr>
@@ -8096,6 +8320,10 @@
           </a:solidFill>
           <a:ln/>
         </p:spPr>
+        <p:txBody>
+          <a:bodyPr/>
+          <a:p/>
+        </p:txBody>
       </p:sp>
       <p:sp>
         <p:nvSpPr>
@@ -8247,7 +8475,7 @@
                 <a:ea typeface="Consolas" pitchFamily="34" charset="-122"/>
                 <a:cs typeface="Consolas" pitchFamily="34" charset="-120"/>
               </a:rPr>
-              <a:t>📁 03_SRC/</a:t>
+              <a:t>📁 02_SRC/</a:t>
             </a:r>
             <a:endParaRPr lang="en-US" sz="1100" dirty="0"/>
           </a:p>
@@ -8403,7 +8631,7 @@
                 <a:ea typeface="Consolas" pitchFamily="34" charset="-122"/>
                 <a:cs typeface="Consolas" pitchFamily="34" charset="-120"/>
               </a:rPr>
-              <a:t>📁 outputs/</a:t>
+              <a:t>📁 04_outputs/</a:t>
             </a:r>
             <a:endParaRPr lang="en-US" sz="1100" dirty="0"/>
           </a:p>
@@ -8442,7 +8670,7 @@
                 <a:ea typeface="Calibri" pitchFamily="34" charset="-122"/>
                 <a:cs typeface="Calibri" pitchFamily="34" charset="-120"/>
               </a:rPr>
-              <a:t>All file outputs: models, predictions, EDA report</a:t>
+              <a:t>Trained model (.h5), LSTM predictions (.pkl), comparison CSV</a:t>
             </a:r>
             <a:endParaRPr lang="en-US" sz="900" dirty="0"/>
           </a:p>
@@ -8481,7 +8709,7 @@
                 <a:ea typeface="Consolas" pitchFamily="34" charset="-122"/>
                 <a:cs typeface="Consolas" pitchFamily="34" charset="-120"/>
               </a:rPr>
-              <a:t>📁 database/</a:t>
+              <a:t>📁 01_database/</a:t>
             </a:r>
             <a:endParaRPr lang="en-US" sz="1100" dirty="0"/>
           </a:p>
@@ -8520,7 +8748,7 @@
                 <a:ea typeface="Calibri" pitchFamily="34" charset="-122"/>
                 <a:cs typeface="Calibri" pitchFamily="34" charset="-120"/>
               </a:rPr>
-              <a:t>SQLite database</a:t>
+              <a:t>SQLite database (bike_orders_database.sqlite)</a:t>
             </a:r>
             <a:endParaRPr lang="en-US" sz="900" dirty="0"/>
           </a:p>
@@ -8598,7 +8826,7 @@
                 <a:ea typeface="Calibri" pitchFamily="34" charset="-122"/>
                 <a:cs typeface="Calibri" pitchFamily="34" charset="-120"/>
               </a:rPr>
-              <a:t>Python dependencies</a:t>
+              <a:t>App runtime deps (no TensorFlow)</a:t>
             </a:r>
             <a:endParaRPr lang="en-US" sz="900" dirty="0"/>
           </a:p>
@@ -8708,6 +8936,10 @@
             </a:outerShdw>
           </a:effectLst>
         </p:spPr>
+        <p:txBody>
+          <a:bodyPr/>
+          <a:p/>
+        </p:txBody>
       </p:sp>
       <p:sp>
         <p:nvSpPr>
@@ -8733,6 +8965,10 @@
             <a:prstDash val="solid"/>
           </a:ln>
         </p:spPr>
+        <p:txBody>
+          <a:bodyPr/>
+          <a:p/>
+        </p:txBody>
       </p:sp>
       <p:sp>
         <p:nvSpPr>
@@ -8838,6 +9074,10 @@
             </a:outerShdw>
           </a:effectLst>
         </p:spPr>
+        <p:txBody>
+          <a:bodyPr/>
+          <a:p/>
+        </p:txBody>
       </p:sp>
       <p:sp>
         <p:nvSpPr>
@@ -8863,6 +9103,10 @@
             <a:prstDash val="solid"/>
           </a:ln>
         </p:spPr>
+        <p:txBody>
+          <a:bodyPr/>
+          <a:p/>
+        </p:txBody>
       </p:sp>
       <p:sp>
         <p:nvSpPr>
@@ -8968,6 +9212,10 @@
             </a:outerShdw>
           </a:effectLst>
         </p:spPr>
+        <p:txBody>
+          <a:bodyPr/>
+          <a:p/>
+        </p:txBody>
       </p:sp>
       <p:sp>
         <p:nvSpPr>
@@ -8993,6 +9241,10 @@
             <a:prstDash val="solid"/>
           </a:ln>
         </p:spPr>
+        <p:txBody>
+          <a:bodyPr/>
+          <a:p/>
+        </p:txBody>
       </p:sp>
       <p:sp>
         <p:nvSpPr>
@@ -9098,6 +9350,10 @@
             </a:outerShdw>
           </a:effectLst>
         </p:spPr>
+        <p:txBody>
+          <a:bodyPr/>
+          <a:p/>
+        </p:txBody>
       </p:sp>
       <p:sp>
         <p:nvSpPr>
@@ -9123,6 +9379,10 @@
             <a:prstDash val="solid"/>
           </a:ln>
         </p:spPr>
+        <p:txBody>
+          <a:bodyPr/>
+          <a:p/>
+        </p:txBody>
       </p:sp>
       <p:sp>
         <p:nvSpPr>
@@ -9258,6 +9518,10 @@
             <a:prstDash val="solid"/>
           </a:ln>
         </p:spPr>
+        <p:txBody>
+          <a:bodyPr/>
+          <a:p/>
+        </p:txBody>
       </p:sp>
       <p:sp>
         <p:nvSpPr>
@@ -9320,6 +9584,10 @@
             <a:prstDash val="solid"/>
           </a:ln>
         </p:spPr>
+        <p:txBody>
+          <a:bodyPr/>
+          <a:p/>
+        </p:txBody>
       </p:sp>
       <p:sp>
         <p:nvSpPr>
@@ -9430,7 +9698,7 @@
                 <a:ea typeface="Calibri" pitchFamily="34" charset="-122"/>
                 <a:cs typeface="Calibri" pitchFamily="34" charset="-120"/>
               </a:rPr>
-              <a:t>AutoARIMA beats a naive forecast at every grouping level (MASE 0.45–0.79)</a:t>
+              <a:t>LSTM wins (MASE 0.703); AutoARIMA close behind (MASE 0.778) — both beat naïve</a:t>
             </a:r>
             <a:endParaRPr lang="en-US" sz="1300" dirty="0"/>
           </a:p>
@@ -9448,7 +9716,7 @@
                 <a:ea typeface="Calibri" pitchFamily="34" charset="-122"/>
                 <a:cs typeface="Calibri" pitchFamily="34" charset="-120"/>
               </a:rPr>
-              <a:t>AutoARIMA remains valuable for interpretable, smooth forecasts</a:t>
+              <a:t>AutoARIMA valuable for per-series CI bands without GPU</a:t>
             </a:r>
             <a:endParaRPr lang="en-US" sz="1300" dirty="0"/>
           </a:p>
@@ -9599,7 +9867,7 @@
                 <a:ea typeface="Calibri" pitchFamily="34" charset="-122"/>
                 <a:cs typeface="Calibri" pitchFamily="34" charset="-120"/>
               </a:rPr>
-              <a:t>Build an interactive forecasting dashboard</a:t>
+              <a:t>Extend dashboard with real-time data ingestion</a:t>
             </a:r>
             <a:endParaRPr lang="en-US" sz="1300" dirty="0"/>
           </a:p>
@@ -9647,6 +9915,10 @@
             <a:prstDash val="solid"/>
           </a:ln>
         </p:spPr>
+        <p:txBody>
+          <a:bodyPr/>
+          <a:p/>
+        </p:txBody>
       </p:sp>
       <p:sp>
         <p:nvSpPr>
@@ -9681,7 +9953,7 @@
                 <a:ea typeface="Calibri" pitchFamily="34" charset="-122"/>
                 <a:cs typeface="Calibri" pitchFamily="34" charset="-120"/>
               </a:rPr>
-              <a:t>View Interactive Dashboard: </a:t>
+              <a:t>Live Streamlit App on Cloud Run: </a:t>
             </a:r>
             <a:pPr algn="l" indent="0" marL="0">
               <a:buNone/>
@@ -9695,7 +9967,7 @@
                 <a:ea typeface="Calibri" pitchFamily="34" charset="-122"/>
                 <a:cs typeface="Calibri" pitchFamily="34" charset="-120"/>
               </a:rPr>
-              <a:t>https://public.tableau.com/app/profile/ella.claude/viz/BikesslaesForecast/Story1</a:t>
+              <a:t>Live App: https://bikes-forecast-6trxjbynbq-uc.a.run.app</a:t>
             </a:r>
             <a:endParaRPr lang="en-US" sz="1200" dirty="0"/>
           </a:p>
@@ -9725,6 +9997,10 @@
             <a:prstDash val="solid"/>
           </a:ln>
         </p:spPr>
+        <p:txBody>
+          <a:bodyPr/>
+          <a:p/>
+        </p:txBody>
       </p:sp>
     </p:spTree>
   </p:cSld>

</xml_diff>

<commit_message>
Add model comparison table to slide 6 (Model Performance Comparison)
Replace bar chart placeholder with styled OOXML table showing LSTM,
AutoARIMA, and Naïve Baseline metrics (MAE, RMSE, MASE). LSTM row
highlighted in teal as winner; note explains MAPE exclusion.

Co-Authored-By: Claude Sonnet 4.6 <noreply@anthropic.com>
</commit_message>
<xml_diff>
--- a/Bikes_Sales_Forecast_Presentation.pptx
+++ b/Bikes_Sales_Forecast_Presentation.pptx
@@ -7150,17 +7150,454 @@
       </p:sp>
       <p:graphicFrame>
         <p:nvGraphicFramePr>
-          <p:cNvPr id="4" name="Chart 0" descr=""/>
-          <p:cNvGraphicFramePr/>
+          <p:cNvPr id="4" name="Table 0"/>
+          <p:cNvGraphicFramePr>
+            <a:graphicFrameLocks noGrp="1"/>
+          </p:cNvGraphicFramePr>
           <p:nvPr/>
         </p:nvGraphicFramePr>
         <p:xfrm>
-          <a:off x="457200" y="914400"/>
-          <a:ext cx="5029200" cy="3657600"/>
+          <a:off x="457200" y="960000"/>
+          <a:ext cx="5029200" cy="3600000"/>
         </p:xfrm>
-        <a:graphic xmlns:a="http://schemas.openxmlformats.org/drawingml/2006/main">
-          <a:graphicData uri="http://schemas.openxmlformats.org/drawingml/2006/chart">
-            <c:chart xmlns:c="http://schemas.openxmlformats.org/drawingml/2006/chart" r:id="rId1"/>
+        <a:graphic>
+          <a:graphicData uri="http://schemas.openxmlformats.org/drawingml/2006/table">
+            <a:tbl>
+              <a:tblPr firstRow="1" bandRow="0">
+                <a:tableStyleId>{5C22544A-7EE6-4342-B048-85BDC9FD1C3A}</a:tableStyleId>
+              </a:tblPr>
+              <a:tblGrid>
+                <a:gridCol w="1700000"/>
+                <a:gridCol w="1109400"/>
+                <a:gridCol w="1109400"/>
+                <a:gridCol w="1110400"/>
+              </a:tblGrid>
+              <a:tr h="560000">
+                <a:tc>
+                  <a:txBody>
+                    <a:bodyPr/>
+                    <a:lstStyle/>
+                    <a:p>
+                      <a:pPr algn="ctr"/>
+                      <a:r>
+                        <a:rPr lang="en-US" sz="1200" b="1" dirty="0">
+                          <a:solidFill>
+                            <a:srgbClr val="FFFFFF"/>
+                          </a:solidFill>
+                          <a:latin typeface="Calibri"/>
+                        </a:rPr>
+                        <a:t>Model</a:t>
+                      </a:r>
+                    </a:p>
+                  </a:txBody>
+                  <a:tcPr>
+                    <a:solidFill>
+                      <a:srgbClr val="065A82"/>
+                    </a:solidFill>
+                  </a:tcPr>
+                </a:tc>
+                <a:tc>
+                  <a:txBody>
+                    <a:bodyPr/>
+                    <a:lstStyle/>
+                    <a:p>
+                      <a:pPr algn="ctr"/>
+                      <a:r>
+                        <a:rPr lang="en-US" sz="1200" b="1" dirty="0">
+                          <a:solidFill>
+                            <a:srgbClr val="FFFFFF"/>
+                          </a:solidFill>
+                          <a:latin typeface="Calibri"/>
+                        </a:rPr>
+                        <a:t>MAE (avg)</a:t>
+                      </a:r>
+                    </a:p>
+                  </a:txBody>
+                  <a:tcPr>
+                    <a:solidFill>
+                      <a:srgbClr val="065A82"/>
+                    </a:solidFill>
+                  </a:tcPr>
+                </a:tc>
+                <a:tc>
+                  <a:txBody>
+                    <a:bodyPr/>
+                    <a:lstStyle/>
+                    <a:p>
+                      <a:pPr algn="ctr"/>
+                      <a:r>
+                        <a:rPr lang="en-US" sz="1200" b="1" dirty="0">
+                          <a:solidFill>
+                            <a:srgbClr val="FFFFFF"/>
+                          </a:solidFill>
+                          <a:latin typeface="Calibri"/>
+                        </a:rPr>
+                        <a:t>RMSE (avg)</a:t>
+                      </a:r>
+                    </a:p>
+                  </a:txBody>
+                  <a:tcPr>
+                    <a:solidFill>
+                      <a:srgbClr val="065A82"/>
+                    </a:solidFill>
+                  </a:tcPr>
+                </a:tc>
+                <a:tc>
+                  <a:txBody>
+                    <a:bodyPr/>
+                    <a:lstStyle/>
+                    <a:p>
+                      <a:pPr algn="ctr"/>
+                      <a:r>
+                        <a:rPr lang="en-US" sz="1200" b="1" dirty="0">
+                          <a:solidFill>
+                            <a:srgbClr val="FFFFFF"/>
+                          </a:solidFill>
+                          <a:latin typeface="Calibri"/>
+                        </a:rPr>
+                        <a:t>MASE (avg)</a:t>
+                      </a:r>
+                    </a:p>
+                  </a:txBody>
+                  <a:tcPr>
+                    <a:solidFill>
+                      <a:srgbClr val="065A82"/>
+                    </a:solidFill>
+                  </a:tcPr>
+                </a:tc>
+              </a:tr>
+              <a:tr h="860000">
+                <a:tc>
+                  <a:txBody>
+                    <a:bodyPr/>
+                    <a:lstStyle/>
+                    <a:p>
+                      <a:pPr algn="l"/>
+                      <a:r>
+                        <a:rPr lang="en-US" sz="1400" b="1" dirty="0">
+                          <a:solidFill>
+                            <a:srgbClr val="FFFFFF"/>
+                          </a:solidFill>
+                          <a:latin typeface="Calibri"/>
+                        </a:rPr>
+                        <a:t>🏆 LSTM</a:t>
+                      </a:r>
+                    </a:p>
+                  </a:txBody>
+                  <a:tcPr>
+                    <a:solidFill>
+                      <a:srgbClr val="028090"/>
+                    </a:solidFill>
+                  </a:tcPr>
+                </a:tc>
+                <a:tc>
+                  <a:txBody>
+                    <a:bodyPr/>
+                    <a:lstStyle/>
+                    <a:p>
+                      <a:pPr algn="ctr"/>
+                      <a:r>
+                        <a:rPr lang="en-US" sz="1400" b="1" dirty="0">
+                          <a:solidFill>
+                            <a:srgbClr val="FFFFFF"/>
+                          </a:solidFill>
+                          <a:latin typeface="Calibri"/>
+                        </a:rPr>
+                        <a:t>$31,981</a:t>
+                      </a:r>
+                    </a:p>
+                  </a:txBody>
+                  <a:tcPr>
+                    <a:solidFill>
+                      <a:srgbClr val="028090"/>
+                    </a:solidFill>
+                  </a:tcPr>
+                </a:tc>
+                <a:tc>
+                  <a:txBody>
+                    <a:bodyPr/>
+                    <a:lstStyle/>
+                    <a:p>
+                      <a:pPr algn="ctr"/>
+                      <a:r>
+                        <a:rPr lang="en-US" sz="1400" b="1" dirty="0">
+                          <a:solidFill>
+                            <a:srgbClr val="FFFFFF"/>
+                          </a:solidFill>
+                          <a:latin typeface="Calibri"/>
+                        </a:rPr>
+                        <a:t>$38,165</a:t>
+                      </a:r>
+                    </a:p>
+                  </a:txBody>
+                  <a:tcPr>
+                    <a:solidFill>
+                      <a:srgbClr val="028090"/>
+                    </a:solidFill>
+                  </a:tcPr>
+                </a:tc>
+                <a:tc>
+                  <a:txBody>
+                    <a:bodyPr/>
+                    <a:lstStyle/>
+                    <a:p>
+                      <a:pPr algn="ctr"/>
+                      <a:r>
+                        <a:rPr lang="en-US" sz="1400" b="1" dirty="0">
+                          <a:solidFill>
+                            <a:srgbClr val="FFFFFF"/>
+                          </a:solidFill>
+                          <a:latin typeface="Calibri"/>
+                        </a:rPr>
+                        <a:t>0.703 ✓</a:t>
+                      </a:r>
+                    </a:p>
+                  </a:txBody>
+                  <a:tcPr>
+                    <a:solidFill>
+                      <a:srgbClr val="028090"/>
+                    </a:solidFill>
+                  </a:tcPr>
+                </a:tc>
+              </a:tr>
+              <a:tr h="860000">
+                <a:tc>
+                  <a:txBody>
+                    <a:bodyPr/>
+                    <a:lstStyle/>
+                    <a:p>
+                      <a:pPr algn="l"/>
+                      <a:r>
+                        <a:rPr lang="en-US" sz="1400" b="1" dirty="0">
+                          <a:solidFill>
+                            <a:srgbClr val="065A82"/>
+                          </a:solidFill>
+                          <a:latin typeface="Calibri"/>
+                        </a:rPr>
+                        <a:t>AutoARIMA</a:t>
+                      </a:r>
+                    </a:p>
+                  </a:txBody>
+                  <a:tcPr>
+                    <a:solidFill>
+                      <a:srgbClr val="E8F4F8"/>
+                    </a:solidFill>
+                  </a:tcPr>
+                </a:tc>
+                <a:tc>
+                  <a:txBody>
+                    <a:bodyPr/>
+                    <a:lstStyle/>
+                    <a:p>
+                      <a:pPr algn="ctr"/>
+                      <a:r>
+                        <a:rPr lang="en-US" sz="1400" dirty="0">
+                          <a:solidFill>
+                            <a:srgbClr val="1E293B"/>
+                          </a:solidFill>
+                          <a:latin typeface="Calibri"/>
+                        </a:rPr>
+                        <a:t>$34,688</a:t>
+                      </a:r>
+                    </a:p>
+                  </a:txBody>
+                  <a:tcPr>
+                    <a:solidFill>
+                      <a:srgbClr val="E8F4F8"/>
+                    </a:solidFill>
+                  </a:tcPr>
+                </a:tc>
+                <a:tc>
+                  <a:txBody>
+                    <a:bodyPr/>
+                    <a:lstStyle/>
+                    <a:p>
+                      <a:pPr algn="ctr"/>
+                      <a:r>
+                        <a:rPr lang="en-US" sz="1400" dirty="0">
+                          <a:solidFill>
+                            <a:srgbClr val="1E293B"/>
+                          </a:solidFill>
+                          <a:latin typeface="Calibri"/>
+                        </a:rPr>
+                        <a:t>$39,689</a:t>
+                      </a:r>
+                    </a:p>
+                  </a:txBody>
+                  <a:tcPr>
+                    <a:solidFill>
+                      <a:srgbClr val="E8F4F8"/>
+                    </a:solidFill>
+                  </a:tcPr>
+                </a:tc>
+                <a:tc>
+                  <a:txBody>
+                    <a:bodyPr/>
+                    <a:lstStyle/>
+                    <a:p>
+                      <a:pPr algn="ctr"/>
+                      <a:r>
+                        <a:rPr lang="en-US" sz="1400" dirty="0">
+                          <a:solidFill>
+                            <a:srgbClr val="1E293B"/>
+                          </a:solidFill>
+                          <a:latin typeface="Calibri"/>
+                        </a:rPr>
+                        <a:t>0.778 ✓</a:t>
+                      </a:r>
+                    </a:p>
+                  </a:txBody>
+                  <a:tcPr>
+                    <a:solidFill>
+                      <a:srgbClr val="E8F4F8"/>
+                    </a:solidFill>
+                  </a:tcPr>
+                </a:tc>
+              </a:tr>
+              <a:tr h="860000">
+                <a:tc>
+                  <a:txBody>
+                    <a:bodyPr/>
+                    <a:lstStyle/>
+                    <a:p>
+                      <a:pPr algn="l"/>
+                      <a:r>
+                        <a:rPr lang="en-US" sz="1400" dirty="0">
+                          <a:solidFill>
+                            <a:srgbClr val="4A5568"/>
+                          </a:solidFill>
+                          <a:latin typeface="Calibri"/>
+                        </a:rPr>
+                        <a:t>Naïve Baseline</a:t>
+                      </a:r>
+                    </a:p>
+                  </a:txBody>
+                  <a:tcPr>
+                    <a:solidFill>
+                      <a:srgbClr val="F5F5F5"/>
+                    </a:solidFill>
+                  </a:tcPr>
+                </a:tc>
+                <a:tc>
+                  <a:txBody>
+                    <a:bodyPr/>
+                    <a:lstStyle/>
+                    <a:p>
+                      <a:pPr algn="ctr"/>
+                      <a:r>
+                        <a:rPr lang="en-US" sz="1400" dirty="0">
+                          <a:solidFill>
+                            <a:srgbClr val="4A5568"/>
+                          </a:solidFill>
+                          <a:latin typeface="Calibri"/>
+                        </a:rPr>
+                        <a:t>$26,612</a:t>
+                      </a:r>
+                    </a:p>
+                  </a:txBody>
+                  <a:tcPr>
+                    <a:solidFill>
+                      <a:srgbClr val="F5F5F5"/>
+                    </a:solidFill>
+                  </a:tcPr>
+                </a:tc>
+                <a:tc>
+                  <a:txBody>
+                    <a:bodyPr/>
+                    <a:lstStyle/>
+                    <a:p>
+                      <a:pPr algn="ctr"/>
+                      <a:r>
+                        <a:rPr lang="en-US" sz="1400" dirty="0">
+                          <a:solidFill>
+                            <a:srgbClr val="4A5568"/>
+                          </a:solidFill>
+                          <a:latin typeface="Calibri"/>
+                        </a:rPr>
+                        <a:t>$36,551</a:t>
+                      </a:r>
+                    </a:p>
+                  </a:txBody>
+                  <a:tcPr>
+                    <a:solidFill>
+                      <a:srgbClr val="F5F5F5"/>
+                    </a:solidFill>
+                  </a:tcPr>
+                </a:tc>
+                <a:tc>
+                  <a:txBody>
+                    <a:bodyPr/>
+                    <a:lstStyle/>
+                    <a:p>
+                      <a:pPr algn="ctr"/>
+                      <a:r>
+                        <a:rPr lang="en-US" sz="1400" dirty="0">
+                          <a:solidFill>
+                            <a:srgbClr val="4A5568"/>
+                          </a:solidFill>
+                          <a:latin typeface="Calibri"/>
+                        </a:rPr>
+                        <a:t>1.000</a:t>
+                      </a:r>
+                    </a:p>
+                  </a:txBody>
+                  <a:tcPr>
+                    <a:solidFill>
+                      <a:srgbClr val="F5F5F5"/>
+                    </a:solidFill>
+                  </a:tcPr>
+                </a:tc>
+              </a:tr>
+              <a:tr h="460000">
+                <a:tc gridSpan="4">
+                  <a:txBody>
+                    <a:bodyPr/>
+                    <a:lstStyle/>
+                    <a:p>
+                      <a:pPr algn="l"/>
+                      <a:r>
+                        <a:rPr lang="en-US" sz="900" i="1" dirty="0">
+                          <a:solidFill>
+                            <a:srgbClr val="4A5568"/>
+                          </a:solidFill>
+                          <a:latin typeface="Calibri"/>
+                        </a:rPr>
+                        <a:t>MASE &lt; 1 beats naïve baseline. MAPE excluded — near-zero monthly sales cause division-by-zero distortion. Holdout: last 3 months, 30 bikeshops.</a:t>
+                      </a:r>
+                    </a:p>
+                  </a:txBody>
+                  <a:tcPr>
+                    <a:solidFill>
+                      <a:srgbClr val="FFFFFF"/>
+                    </a:solidFill>
+                  </a:tcPr>
+                </a:tc>
+                <a:tc hMerge="1">
+                  <a:txBody>
+                    <a:bodyPr/>
+                    <a:lstStyle/>
+                    <a:p/>
+                  </a:txBody>
+                  <a:tcPr/>
+                </a:tc>
+                <a:tc hMerge="1">
+                  <a:txBody>
+                    <a:bodyPr/>
+                    <a:lstStyle/>
+                    <a:p/>
+                  </a:txBody>
+                  <a:tcPr/>
+                </a:tc>
+                <a:tc hMerge="1">
+                  <a:txBody>
+                    <a:bodyPr/>
+                    <a:lstStyle/>
+                    <a:p/>
+                  </a:txBody>
+                  <a:tcPr/>
+                </a:tc>
+              </a:tr>
+            </a:tbl>
           </a:graphicData>
         </a:graphic>
       </p:graphicFrame>

</xml_diff>